<commit_message>
Added Demo video link
</commit_message>
<xml_diff>
--- a/deck/PRD_Genie_Capstone_Deck.pptx
+++ b/deck/PRD_Genie_Capstone_Deck.pptx
@@ -1339,7 +1339,7 @@
           </a:prstGeom>
           <a:extLst>
             <a:ext uri="{C572A759-6A51-4108-AA02-DFA0A04FC94B}">
-              <ma14:wrappingTextBoxFlag xmlns="" xmlns:ma14="http://schemas.microsoft.com/office/mac/drawingml/2011/main" val="0"/>
+              <ma14:wrappingTextBoxFlag xmlns:ma14="http://schemas.microsoft.com/office/mac/drawingml/2011/main" xmlns="" val="0"/>
             </a:ext>
           </a:extLst>
         </p:spPr>
@@ -1535,7 +1535,7 @@
           </a:prstGeom>
           <a:extLst>
             <a:ext uri="{C572A759-6A51-4108-AA02-DFA0A04FC94B}">
-              <ma14:wrappingTextBoxFlag xmlns="" xmlns:ma14="http://schemas.microsoft.com/office/mac/drawingml/2011/main" val="0"/>
+              <ma14:wrappingTextBoxFlag xmlns:ma14="http://schemas.microsoft.com/office/mac/drawingml/2011/main" xmlns="" val="0"/>
             </a:ext>
           </a:extLst>
         </p:spPr>
@@ -1846,7 +1846,7 @@
           </a:prstGeom>
           <a:extLst>
             <a:ext uri="{C572A759-6A51-4108-AA02-DFA0A04FC94B}">
-              <ma14:wrappingTextBoxFlag xmlns="" xmlns:ma14="http://schemas.microsoft.com/office/mac/drawingml/2011/main" val="0"/>
+              <ma14:wrappingTextBoxFlag xmlns:ma14="http://schemas.microsoft.com/office/mac/drawingml/2011/main" xmlns="" val="0"/>
             </a:ext>
           </a:extLst>
         </p:spPr>
@@ -1921,7 +1921,7 @@
           </a:prstGeom>
           <a:extLst>
             <a:ext uri="{C572A759-6A51-4108-AA02-DFA0A04FC94B}">
-              <ma14:wrappingTextBoxFlag xmlns="" xmlns:ma14="http://schemas.microsoft.com/office/mac/drawingml/2011/main" val="0"/>
+              <ma14:wrappingTextBoxFlag xmlns:ma14="http://schemas.microsoft.com/office/mac/drawingml/2011/main" xmlns="" val="0"/>
             </a:ext>
           </a:extLst>
         </p:spPr>
@@ -2749,24 +2749,6 @@
                   <a:schemeClr val="accent4"/>
                 </a:solidFill>
               </a:rPr>
-              <a:t>The human approval step is designed, not built.</a:t>
-            </a:r>
-            <a:endParaRPr lang="en-US" sz="1800" dirty="0"/>
-          </a:p>
-          <a:p>
-            <a:pPr marL="342900" indent="-342900">
-              <a:spcAft>
-                <a:spcPts val="600"/>
-              </a:spcAft>
-              <a:buSzPct val="100000"/>
-              <a:buChar char="•"/>
-            </a:pPr>
-            <a:r>
-              <a:rPr lang="en-US" sz="1800" dirty="0">
-                <a:solidFill>
-                  <a:schemeClr val="accent4"/>
-                </a:solidFill>
-              </a:rPr>
               <a:t>The Drive path is not in the automated suite.</a:t>
             </a:r>
             <a:endParaRPr lang="en-US" sz="1800" dirty="0"/>
@@ -2916,7 +2898,7 @@
                   <a:schemeClr val="accent4"/>
                 </a:solidFill>
               </a:rPr>
-              <a:t>Add an approval step before PRD generation.</a:t>
+              <a:t>Build a held-out set from anonymized real transcripts.</a:t>
             </a:r>
             <a:endParaRPr lang="en-US" sz="1800" dirty="0"/>
           </a:p>
@@ -2934,7 +2916,7 @@
                   <a:schemeClr val="accent4"/>
                 </a:solidFill>
               </a:rPr>
-              <a:t>Build a held-out set from anonymized real transcripts.</a:t>
+              <a:t>Move tracing to OpenTelemetry before 16 November 2026.</a:t>
             </a:r>
             <a:endParaRPr lang="en-US" sz="1800" dirty="0"/>
           </a:p>
@@ -2952,25 +2934,7 @@
                   <a:schemeClr val="accent4"/>
                 </a:solidFill>
               </a:rPr>
-              <a:t>Move tracing to OpenTelemetry before 16 November 2026.</a:t>
-            </a:r>
-            <a:endParaRPr lang="en-US" sz="1800" dirty="0"/>
-          </a:p>
-          <a:p>
-            <a:pPr marL="342900" indent="-342900">
-              <a:spcAft>
-                <a:spcPts val="600"/>
-              </a:spcAft>
-              <a:buSzPct val="100000"/>
-              <a:buChar char="•"/>
-            </a:pPr>
-            <a:r>
-              <a:rPr lang="en-US" sz="1800" dirty="0">
-                <a:solidFill>
-                  <a:schemeClr val="accent4"/>
-                </a:solidFill>
-              </a:rPr>
-              <a:t>Split multi-meeting files before processing.</a:t>
+              <a:t>Split multi-meeting/muti-transcript files before processing.</a:t>
             </a:r>
             <a:endParaRPr lang="en-US" sz="1800" dirty="0"/>
           </a:p>
@@ -3048,7 +3012,7 @@
           </a:prstGeom>
           <a:extLst>
             <a:ext uri="{C572A759-6A51-4108-AA02-DFA0A04FC94B}">
-              <ma14:wrappingTextBoxFlag xmlns="" xmlns:ma14="http://schemas.microsoft.com/office/mac/drawingml/2011/main" val="0"/>
+              <ma14:wrappingTextBoxFlag xmlns:ma14="http://schemas.microsoft.com/office/mac/drawingml/2011/main" xmlns="" val="0"/>
             </a:ext>
           </a:extLst>
         </p:spPr>
@@ -3814,7 +3778,7 @@
           </a:prstGeom>
           <a:extLst>
             <a:ext uri="{C572A759-6A51-4108-AA02-DFA0A04FC94B}">
-              <ma14:wrappingTextBoxFlag xmlns="" xmlns:ma14="http://schemas.microsoft.com/office/mac/drawingml/2011/main" val="0"/>
+              <ma14:wrappingTextBoxFlag xmlns:ma14="http://schemas.microsoft.com/office/mac/drawingml/2011/main" xmlns="" val="0"/>
             </a:ext>
           </a:extLst>
         </p:spPr>
@@ -4582,7 +4546,7 @@
           </a:prstGeom>
           <a:extLst>
             <a:ext uri="{C572A759-6A51-4108-AA02-DFA0A04FC94B}">
-              <ma14:wrappingTextBoxFlag xmlns="" xmlns:ma14="http://schemas.microsoft.com/office/mac/drawingml/2011/main" val="0"/>
+              <ma14:wrappingTextBoxFlag xmlns:ma14="http://schemas.microsoft.com/office/mac/drawingml/2011/main" xmlns="" val="0"/>
             </a:ext>
           </a:extLst>
         </p:spPr>
@@ -5780,7 +5744,7 @@
           </a:prstGeom>
           <a:extLst>
             <a:ext uri="{C572A759-6A51-4108-AA02-DFA0A04FC94B}">
-              <ma14:wrappingTextBoxFlag xmlns="" xmlns:ma14="http://schemas.microsoft.com/office/mac/drawingml/2011/main" val="0"/>
+              <ma14:wrappingTextBoxFlag xmlns:ma14="http://schemas.microsoft.com/office/mac/drawingml/2011/main" xmlns="" val="0"/>
             </a:ext>
           </a:extLst>
         </p:spPr>
@@ -6510,7 +6474,7 @@
           </a:prstGeom>
           <a:extLst>
             <a:ext uri="{C572A759-6A51-4108-AA02-DFA0A04FC94B}">
-              <ma14:wrappingTextBoxFlag xmlns="" xmlns:ma14="http://schemas.microsoft.com/office/mac/drawingml/2011/main" val="0"/>
+              <ma14:wrappingTextBoxFlag xmlns:ma14="http://schemas.microsoft.com/office/mac/drawingml/2011/main" xmlns="" val="0"/>
             </a:ext>
           </a:extLst>
         </p:spPr>
@@ -7279,7 +7243,7 @@
           </a:prstGeom>
           <a:extLst>
             <a:ext uri="{C572A759-6A51-4108-AA02-DFA0A04FC94B}">
-              <ma14:wrappingTextBoxFlag xmlns="" xmlns:ma14="http://schemas.microsoft.com/office/mac/drawingml/2011/main" val="0"/>
+              <ma14:wrappingTextBoxFlag xmlns:ma14="http://schemas.microsoft.com/office/mac/drawingml/2011/main" xmlns="" val="0"/>
             </a:ext>
           </a:extLst>
         </p:spPr>
@@ -7812,7 +7776,7 @@
           </a:prstGeom>
           <a:extLst>
             <a:ext uri="{C572A759-6A51-4108-AA02-DFA0A04FC94B}">
-              <ma14:wrappingTextBoxFlag xmlns="" xmlns:ma14="http://schemas.microsoft.com/office/mac/drawingml/2011/main" val="0"/>
+              <ma14:wrappingTextBoxFlag xmlns:ma14="http://schemas.microsoft.com/office/mac/drawingml/2011/main" xmlns="" val="0"/>
             </a:ext>
           </a:extLst>
         </p:spPr>
@@ -8397,7 +8361,7 @@
           </a:prstGeom>
           <a:extLst>
             <a:ext uri="{C572A759-6A51-4108-AA02-DFA0A04FC94B}">
-              <ma14:wrappingTextBoxFlag xmlns="" xmlns:ma14="http://schemas.microsoft.com/office/mac/drawingml/2011/main" val="0"/>
+              <ma14:wrappingTextBoxFlag xmlns:ma14="http://schemas.microsoft.com/office/mac/drawingml/2011/main" xmlns="" val="0"/>
             </a:ext>
           </a:extLst>
         </p:spPr>
@@ -8937,7 +8901,7 @@
           </a:prstGeom>
           <a:extLst>
             <a:ext uri="{C572A759-6A51-4108-AA02-DFA0A04FC94B}">
-              <ma14:wrappingTextBoxFlag xmlns="" xmlns:ma14="http://schemas.microsoft.com/office/mac/drawingml/2011/main" val="0"/>
+              <ma14:wrappingTextBoxFlag xmlns:ma14="http://schemas.microsoft.com/office/mac/drawingml/2011/main" xmlns="" val="0"/>
             </a:ext>
           </a:extLst>
         </p:spPr>

</xml_diff>